<commit_message>
fix(topics): 框架版改用 assign_sub，Colab 的 Keras 3 已移除 legacy optimizer
學生在 Colab 跑到 ImportError：Colab 的 TensorFlow 是 2.20／Keras 3，
tf.keras.optimizers.legacy 整個被移除。本機是 TF 2.13 所以測得過。

改用 w.assign_sub(eta * g)，沒有版本相依，而且把更新式直接寫出來。
另加一格示範 optimizers.SGD 並包了 try/except，API 再變也只會印訊息不會中斷。
數字不變：手寫版與框架版最大差仍是 1.91e-07，optimizer 版與 assign_sub 版差 0.00e+00。

由 gen_dlma_repo.py 產生，勿直接編輯。

Co-Authored-By: Claude Opus 5 <noreply@anthropic.com>
Claude-Session: https://claude.ai/code/session_01GYA9K6Yp6Rme6Ub4bCZdGK
</commit_message>
<xml_diff>
--- a/topics/gradient-descent/課外主題_梯度下降法.pptx
+++ b/topics/gradient-descent/課外主題_梯度下降法.pptx
@@ -3943,7 +3943,7 @@
                 </a:solidFill>
                 <a:latin typeface="Consolas"/>
               </a:rPr>
-              <a:t>opt = tf.keras.optimizers.legacy.SGD(0.1)</a:t>
+              <a:t>eta = 0.1</a:t>
             </a:r>
           </a:p>
           <a:p>
@@ -4015,7 +4015,7 @@
                 </a:solidFill>
                 <a:latin typeface="Consolas"/>
               </a:rPr>
-              <a:t>    opt.apply_gradients([(g, w)])</a:t>
+              <a:t>    w.assign_sub(eta * g)       # 就是更新式</a:t>
             </a:r>
           </a:p>
         </p:txBody>

</xml_diff>